<commit_message>
Add Part 2 summary figure slide and fade transitions
Re-plot the facts-vs-skills scatter without confidence intervals, add it
as a summary slide before the closing, and give every slide a plain fade.

Co-Authored-By: Claude Fable 5.1 <noreply@anthropic.com>
Claude-Session: https://claude.ai/code/session_01MX2Q6ty2VvPt85qQewxwes
</commit_message>
<xml_diff>
--- a/slides/Retrain_or_teach.pptx
+++ b/slides/Retrain_or_teach.pptx
@@ -18,9 +18,10 @@
     <p:sldId id="266" r:id="rId12"/>
     <p:sldId id="267" r:id="rId13"/>
     <p:sldId id="268" r:id="rId14"/>
+    <p:sldId id="269" r:id="rId15"/>
   </p:sldIdLst>
   <p:notesMasterIdLst>
-    <p:notesMasterId r:id="rId15"/>
+    <p:notesMasterId r:id="rId16"/>
   </p:notesMasterIdLst>
   <p:sldSz cx="12192000" cy="6858000"/>
   <p:notesSz cx="6858000" cy="12192000"/>
@@ -119,7 +120,7 @@
   <p:extLst>
     <p:ext uri="{521415D9-36F7-43E2-AB2F-B90AF26B5E84}">
       <p14:sectionLst xmlns:p14="http://schemas.microsoft.com/office/powerpoint/2010/main">
-        <p14:section name="Part 1: It already knows more than it says" id="{66b3dc1e-e2ec-3876-cb43-5119ee88c72f}">
+        <p14:section name="Part 1: It already knows more than it says" id="{e80d6549-61f7-4b41-be94-c88098532136}">
           <p14:sldIdLst>
             <p14:sldId id="256"/>
             <p14:sldId id="257"/>
@@ -127,7 +128,7 @@
             <p14:sldId id="259"/>
           </p14:sldIdLst>
         </p14:section>
-        <p14:section name="Part 2: It needs knowledge it never had" id="{b02fff27-f0b5-669f-2b14-b2812e3b7258}">
+        <p14:section name="Part 2: It needs knowledge it never had" id="{b880f0b8-97d7-53b9-ca19-3ce921404b00}">
           <p14:sldIdLst>
             <p14:sldId id="260"/>
             <p14:sldId id="261"/>
@@ -136,12 +137,13 @@
             <p14:sldId id="264"/>
           </p14:sldIdLst>
         </p14:section>
-        <p14:section name="Train separately, average, and why it works" id="{8987a468-eac9-66f3-39cc-0f5e36ea4d56}">
+        <p14:section name="Train separately, average, and why it works" id="{164f90f1-dfaa-cdb7-7946-0c3624ab7ab6}">
           <p14:sldIdLst>
             <p14:sldId id="265"/>
             <p14:sldId id="266"/>
             <p14:sldId id="267"/>
             <p14:sldId id="268"/>
+            <p14:sldId id="269"/>
           </p14:sldIdLst>
         </p14:section>
       </p14:sectionLst>
@@ -900,7 +902,7 @@
           <a:p>
             <a:r>
               <a:rPr lang="en-US" dirty="0"/>
-              <a:t>Retrain or teach? Teach. Does the language matter? Less than you'd think. The question I'm chasing: if new knowledge is a direction we can add, average, and steer, do we ever need to retrain a model from scratch? Thanks.</a:t>
+              <a:t>Part two in one picture. Right means more new facts learned; up means general skills kept. Each single-language update learns but forgets. The mixture learns the most and forgets less. The average of the three single-language models, no extra training, sits top right: as many facts as the mixture and nothing lost.</a:t>
             </a:r>
             <a:endParaRPr lang="en-US" dirty="0"/>
           </a:p>
@@ -924,6 +926,94 @@
             <a:fld id="{F7021451-1387-4CA6-816F-3879F97B5CBC}" type="slidenum">
               <a:rPr lang="en-US"/>
               <a:t>13</a:t>
+            </a:fld>
+            <a:endParaRPr lang="en-US"/>
+          </a:p>
+        </p:txBody>
+      </p:sp>
+    </p:spTree>
+    <p:extLst>
+      <p:ext uri="{BB962C8B-B14F-4D97-AF65-F5344CB8AC3E}">
+        <p14:creationId xmlns:p14="http://schemas.microsoft.com/office/powerpoint/2010/main" val="1024086991"/>
+      </p:ext>
+    </p:extLst>
+  </p:cSld>
+  <p:clrMapOvr>
+    <a:masterClrMapping/>
+  </p:clrMapOvr>
+</p:notes>
+</file>
+
+<file path=ppt/notesSlides/notesSlide14.xml><?xml version="1.0" encoding="utf-8"?>
+<p:notes xmlns:a="http://schemas.openxmlformats.org/drawingml/2006/main" xmlns:r="http://schemas.openxmlformats.org/officeDocument/2006/relationships" xmlns:p="http://schemas.openxmlformats.org/presentationml/2006/main">
+  <p:cSld>
+    <p:spTree>
+      <p:nvGrpSpPr>
+        <p:cNvPr id="1" name=""/>
+        <p:cNvGrpSpPr/>
+        <p:nvPr/>
+      </p:nvGrpSpPr>
+      <p:grpSpPr>
+        <a:xfrm>
+          <a:off x="0" y="0"/>
+          <a:ext cx="0" cy="0"/>
+          <a:chOff x="0" y="0"/>
+          <a:chExt cx="0" cy="0"/>
+        </a:xfrm>
+      </p:grpSpPr>
+      <p:sp>
+        <p:nvSpPr>
+          <p:cNvPr id="2" name="Slide Image Placeholder 1"/>
+          <p:cNvSpPr>
+            <a:spLocks noGrp="1" noRot="1" noChangeAspect="1"/>
+          </p:cNvSpPr>
+          <p:nvPr>
+            <p:ph type="sldImg"/>
+          </p:nvPr>
+        </p:nvSpPr>
+        <p:spPr/>
+      </p:sp>
+      <p:sp>
+        <p:nvSpPr>
+          <p:cNvPr id="3" name="Notes Placeholder 2"/>
+          <p:cNvSpPr>
+            <a:spLocks noGrp="1"/>
+          </p:cNvSpPr>
+          <p:nvPr>
+            <p:ph type="body" idx="1"/>
+          </p:nvPr>
+        </p:nvSpPr>
+        <p:spPr/>
+        <p:txBody>
+          <a:bodyPr/>
+          <a:lstStyle/>
+          <a:p>
+            <a:r>
+              <a:rPr lang="en-US" dirty="0"/>
+              <a:t>Retrain or teach? Teach. Does the language matter? Less than you'd think. The question I'm chasing: if new knowledge is a direction we can add, average, and steer, do we ever need to retrain a model from scratch? Thanks.</a:t>
+            </a:r>
+            <a:endParaRPr lang="en-US" dirty="0"/>
+          </a:p>
+        </p:txBody>
+      </p:sp>
+      <p:sp>
+        <p:nvSpPr>
+          <p:cNvPr id="4" name="Slide Number Placeholder 3"/>
+          <p:cNvSpPr>
+            <a:spLocks noGrp="1"/>
+          </p:cNvSpPr>
+          <p:nvPr>
+            <p:ph type="sldNum" sz="quarter" idx="10"/>
+          </p:nvPr>
+        </p:nvSpPr>
+        <p:spPr/>
+        <p:txBody>
+          <a:bodyPr/>
+          <a:lstStyle/>
+          <a:p>
+            <a:fld id="{F7021451-1387-4CA6-816F-3879F97B5CBC}" type="slidenum">
+              <a:rPr lang="en-US"/>
+              <a:t>14</a:t>
             </a:fld>
             <a:endParaRPr lang="en-US"/>
           </a:p>
@@ -2607,6 +2697,9 @@
   <p:clrMapOvr>
     <a:masterClrMapping/>
   </p:clrMapOvr>
+  <p:transition spd="med">
+    <p:fade/>
+  </p:transition>
 </p:sld>
 </file>
 
@@ -3707,6 +3800,9 @@
   <p:clrMapOvr>
     <a:masterClrMapping/>
   </p:clrMapOvr>
+  <p:transition spd="med">
+    <p:fade/>
+  </p:transition>
 </p:sld>
 </file>
 
@@ -4478,6 +4574,9 @@
   <p:clrMapOvr>
     <a:masterClrMapping/>
   </p:clrMapOvr>
+  <p:transition spd="med">
+    <p:fade/>
+  </p:transition>
 </p:sld>
 </file>
 
@@ -5210,6 +5309,9 @@
   <p:clrMapOvr>
     <a:masterClrMapping/>
   </p:clrMapOvr>
+  <p:transition spd="med">
+    <p:fade/>
+  </p:transition>
 </p:sld>
 </file>
 
@@ -5262,6 +5364,239 @@
                   <a:schemeClr val="accent1"/>
                 </a:solidFill>
               </a:rPr>
+              <a:t>PART 2 · IN ONE PICTURE</a:t>
+            </a:r>
+            <a:endParaRPr lang="en-US" sz="1200" dirty="0"/>
+          </a:p>
+        </p:txBody>
+      </p:sp>
+      <p:sp>
+        <p:nvSpPr>
+          <p:cNvPr id="3" name="Text 0"/>
+          <p:cNvSpPr/>
+          <p:nvPr>
+            <p:ph idx="101" type="title" hasCustomPrompt="1"/>
+          </p:nvPr>
+        </p:nvSpPr>
+        <p:spPr>
+          <a:xfrm>
+            <a:off x="640080" y="731520"/>
+            <a:ext cx="10908792" cy="1097280"/>
+          </a:xfrm>
+          <a:prstGeom prst="rect">
+            <a:avLst/>
+          </a:prstGeom>
+          <a:noFill/>
+          <a:ln/>
+        </p:spPr>
+        <p:txBody>
+          <a:bodyPr wrap="square" lIns="0" tIns="0" rIns="0" bIns="0" rtlCol="0" anchor="t"/>
+          <a:lstStyle/>
+          <a:p>
+            <a:pPr algn="l" indent="0" marL="0">
+              <a:buNone/>
+            </a:pPr>
+            <a:r>
+              <a:rPr lang="en-US" sz="3200" b="1" dirty="0">
+                <a:solidFill>
+                  <a:schemeClr val="tx1"/>
+                </a:solidFill>
+              </a:rPr>
+              <a:t>Every update learns. </a:t>
+            </a:r>
+            <a:pPr algn="l" indent="0" marL="0">
+              <a:buNone/>
+            </a:pPr>
+            <a:r>
+              <a:rPr lang="en-US" sz="3200" b="1" i="1" dirty="0">
+                <a:solidFill>
+                  <a:srgbClr val="6B7280"/>
+                </a:solidFill>
+              </a:rPr>
+              <a:t>Only the average learns without losing.</a:t>
+            </a:r>
+            <a:endParaRPr lang="en-US" sz="3200" dirty="0"/>
+          </a:p>
+        </p:txBody>
+      </p:sp>
+      <p:pic>
+        <p:nvPicPr>
+          <p:cNvPr id="4" name="Image 0" descr="/tmp/claude-0/-home-user-Claude-expo-repo-36501/d3d88de1-f67d-5aa6-8097-3ece5ccf8bcb/scratchpad/build/summary_part2.png">    </p:cNvPr>
+          <p:cNvPicPr>
+            <a:picLocks noChangeAspect="1"/>
+          </p:cNvPicPr>
+          <p:nvPr/>
+        </p:nvPicPr>
+        <p:blipFill>
+          <a:blip r:embed="rId1"/>
+          <a:stretch>
+            <a:fillRect/>
+          </a:stretch>
+        </p:blipFill>
+        <p:spPr>
+          <a:xfrm>
+            <a:off x="2331720" y="1965960"/>
+            <a:ext cx="7498080" cy="3994831"/>
+          </a:xfrm>
+          <a:prstGeom prst="rect">
+            <a:avLst/>
+          </a:prstGeom>
+        </p:spPr>
+      </p:pic>
+      <p:sp>
+        <p:nvSpPr>
+          <p:cNvPr id="5" name="Text 0"/>
+          <p:cNvSpPr/>
+          <p:nvPr>
+            <p:ph idx="102" type="body" hasCustomPrompt="1"/>
+          </p:nvPr>
+        </p:nvSpPr>
+        <p:spPr>
+          <a:xfrm>
+            <a:off x="640080" y="5989320"/>
+            <a:ext cx="10908792" cy="548640"/>
+          </a:xfrm>
+          <a:prstGeom prst="rect">
+            <a:avLst/>
+          </a:prstGeom>
+          <a:noFill/>
+          <a:ln/>
+        </p:spPr>
+        <p:txBody>
+          <a:bodyPr wrap="square" lIns="0" tIns="0" rIns="0" bIns="0" rtlCol="0" anchor="ctr"/>
+          <a:lstStyle/>
+          <a:p>
+            <a:pPr indent="0" marL="0">
+              <a:buNone/>
+            </a:pPr>
+            <a:r>
+              <a:rPr lang="en-US" sz="1800" b="1" dirty="0">
+                <a:solidFill>
+                  <a:schemeClr val="tx1"/>
+                </a:solidFill>
+              </a:rPr>
+              <a:t>Right = more new facts. Up = nothing forgotten. </a:t>
+            </a:r>
+            <a:pPr indent="0" marL="0">
+              <a:buNone/>
+            </a:pPr>
+            <a:r>
+              <a:rPr lang="en-US" sz="1800" b="1" i="1" dirty="0">
+                <a:solidFill>
+                  <a:srgbClr val="6B7280"/>
+                </a:solidFill>
+              </a:rPr>
+              <a:t>Top right is where we want to be.</a:t>
+            </a:r>
+            <a:endParaRPr lang="en-US" sz="1800" dirty="0"/>
+          </a:p>
+        </p:txBody>
+      </p:sp>
+      <p:sp>
+        <p:nvSpPr>
+          <p:cNvPr id="25" name="Slide Number Placeholder 0"/>
+          <p:cNvSpPr>
+            <a:spLocks noGrp="1"/>
+          </p:cNvSpPr>
+          <p:nvPr>
+            <p:ph type="sldNum" sz="quarter" idx="4294967295"/>
+          </p:nvPr>
+        </p:nvSpPr>
+        <p:spPr>
+          <a:xfrm>
+            <a:off x="11247120" y="6446520"/>
+            <a:ext cx="548640" cy="274320"/>
+          </a:xfrm>
+          <a:prstGeom prst="rect">
+            <a:avLst/>
+          </a:prstGeom>
+          <a:extLst>
+            <a:ext uri="{C572A759-6A51-4108-AA02-DFA0A04FC94B}">
+              <ma14:wrappingTextBoxFlag xmlns:ma14="http://schemas.microsoft.com/office/mac/drawingml/2011/main" val="0"/>
+            </a:ext>
+          </a:extLst>
+        </p:spPr>
+        <p:txBody>
+          <a:bodyPr/>
+          <a:lstStyle>
+            <a:lvl1pPr>
+              <a:defRPr sz="1000">
+                <a:solidFill>
+                  <a:srgbClr val="9CA3AF"/>
+                </a:solidFill>
+              </a:defRPr>
+            </a:lvl1pPr>
+          </a:lstStyle>
+          <a:p>
+            <a:pPr algn="l"/>
+            <a:fld id="{F7021451-1387-4CA6-816F-3879F97B5CBC}" type="slidenum">
+              <a:rPr b="0" lang="en-US"/>
+              <a:t>13</a:t>
+            </a:fld>
+            <a:endParaRPr lang="en-US"/>
+          </a:p>
+        </p:txBody>
+      </p:sp>
+    </p:spTree>
+  </p:cSld>
+  <p:clrMapOvr>
+    <a:masterClrMapping/>
+  </p:clrMapOvr>
+  <p:transition spd="med">
+    <p:fade/>
+  </p:transition>
+</p:sld>
+</file>
+
+<file path=ppt/slides/slide14.xml><?xml version="1.0" encoding="utf-8"?>
+<p:sld xmlns:a="http://schemas.openxmlformats.org/drawingml/2006/main" xmlns:r="http://schemas.openxmlformats.org/officeDocument/2006/relationships" xmlns:p="http://schemas.openxmlformats.org/presentationml/2006/main">
+  <p:cSld name="Slide 14">
+    <p:spTree>
+      <p:nvGrpSpPr>
+        <p:cNvPr id="1" name=""/>
+        <p:cNvGrpSpPr/>
+        <p:nvPr/>
+      </p:nvGrpSpPr>
+      <p:grpSpPr>
+        <a:xfrm>
+          <a:off x="0" y="0"/>
+          <a:ext cx="0" cy="0"/>
+          <a:chOff x="0" y="0"/>
+          <a:chExt cx="0" cy="0"/>
+        </a:xfrm>
+      </p:grpSpPr>
+      <p:sp>
+        <p:nvSpPr>
+          <p:cNvPr id="2" name="Text 0"/>
+          <p:cNvSpPr/>
+          <p:nvPr>
+            <p:ph idx="100" type="body" hasCustomPrompt="1"/>
+          </p:nvPr>
+        </p:nvSpPr>
+        <p:spPr>
+          <a:xfrm>
+            <a:off x="640080" y="411480"/>
+            <a:ext cx="10908792" cy="320040"/>
+          </a:xfrm>
+          <a:prstGeom prst="rect">
+            <a:avLst/>
+          </a:prstGeom>
+          <a:noFill/>
+          <a:ln/>
+        </p:spPr>
+        <p:txBody>
+          <a:bodyPr wrap="square" lIns="0" tIns="0" rIns="0" bIns="0" rtlCol="0"/>
+          <a:lstStyle/>
+          <a:p>
+            <a:pPr indent="0" marL="0">
+              <a:buNone/>
+            </a:pPr>
+            <a:r>
+              <a:rPr lang="en-US" sz="1200" b="1" spc="300" kern="0" dirty="0">
+                <a:solidFill>
+                  <a:schemeClr val="accent1"/>
+                </a:solidFill>
+              </a:rPr>
               <a:t>SUMMARY</a:t>
             </a:r>
             <a:endParaRPr lang="en-US" sz="1200" dirty="0"/>
@@ -5681,7 +6016,7 @@
             <a:pPr algn="l"/>
             <a:fld id="{F7021451-1387-4CA6-816F-3879F97B5CBC}" type="slidenum">
               <a:rPr b="0" lang="en-US"/>
-              <a:t>13</a:t>
+              <a:t>14</a:t>
             </a:fld>
             <a:endParaRPr lang="en-US"/>
           </a:p>
@@ -5692,6 +6027,9 @@
   <p:clrMapOvr>
     <a:masterClrMapping/>
   </p:clrMapOvr>
+  <p:transition spd="med">
+    <p:fade/>
+  </p:transition>
 </p:sld>
 </file>
 
@@ -6640,6 +6978,9 @@
   <p:clrMapOvr>
     <a:masterClrMapping/>
   </p:clrMapOvr>
+  <p:transition spd="med">
+    <p:fade/>
+  </p:transition>
 </p:sld>
 </file>
 
@@ -7711,6 +8052,9 @@
   <p:clrMapOvr>
     <a:masterClrMapping/>
   </p:clrMapOvr>
+  <p:transition spd="med">
+    <p:fade/>
+  </p:transition>
 </p:sld>
 </file>
 
@@ -8452,6 +8796,9 @@
   <p:clrMapOvr>
     <a:masterClrMapping/>
   </p:clrMapOvr>
+  <p:transition spd="med">
+    <p:fade/>
+  </p:transition>
 </p:sld>
 </file>
 
@@ -9481,6 +9828,9 @@
   <p:clrMapOvr>
     <a:masterClrMapping/>
   </p:clrMapOvr>
+  <p:transition spd="med">
+    <p:fade/>
+  </p:transition>
 </p:sld>
 </file>
 
@@ -10259,6 +10609,9 @@
   <p:clrMapOvr>
     <a:masterClrMapping/>
   </p:clrMapOvr>
+  <p:transition spd="med">
+    <p:fade/>
+  </p:transition>
 </p:sld>
 </file>
 
@@ -10630,6 +10983,9 @@
   <p:clrMapOvr>
     <a:masterClrMapping/>
   </p:clrMapOvr>
+  <p:transition spd="med">
+    <p:fade/>
+  </p:transition>
 </p:sld>
 </file>
 
@@ -11320,6 +11676,9 @@
   <p:clrMapOvr>
     <a:masterClrMapping/>
   </p:clrMapOvr>
+  <p:transition spd="med">
+    <p:fade/>
+  </p:transition>
 </p:sld>
 </file>
 
@@ -11849,6 +12208,9 @@
   <p:clrMapOvr>
     <a:masterClrMapping/>
   </p:clrMapOvr>
+  <p:transition spd="med">
+    <p:fade/>
+  </p:transition>
 </p:sld>
 </file>
 

</xml_diff>

<commit_message>
Simplify goal slide to two icons and counts
Co-Authored-By: Claude Fable 5.1 <noreply@anthropic.com>
Claude-Session: https://claude.ai/code/session_01MX2Q6ty2VvPt85qQewxwes
</commit_message>
<xml_diff>
--- a/slides/Retrain_or_teach.pptx
+++ b/slides/Retrain_or_teach.pptx
@@ -121,7 +121,7 @@
   <p:extLst>
     <p:ext uri="{521415D9-36F7-43E2-AB2F-B90AF26B5E84}">
       <p14:sectionLst xmlns:p14="http://schemas.microsoft.com/office/powerpoint/2010/main">
-        <p14:section name="Part 1: It already knows more than it says" id="{4797ed7c-0820-0846-37ee-545e47683eea}">
+        <p14:section name="Part 1: It already knows more than it says" id="{6e0d703e-c2cf-01b8-cb05-7ab8dc35ccc6}">
           <p14:sldIdLst>
             <p14:sldId id="256"/>
             <p14:sldId id="257"/>
@@ -130,7 +130,7 @@
             <p14:sldId id="260"/>
           </p14:sldIdLst>
         </p14:section>
-        <p14:section name="Part 2: It needs knowledge it never had" id="{0c8f4e89-8e6f-f847-a948-5fcc20e29426}">
+        <p14:section name="Part 2: It needs knowledge it never had" id="{da8542b0-9e2d-f6d6-a841-609692f5f24f}">
           <p14:sldIdLst>
             <p14:sldId id="261"/>
             <p14:sldId id="262"/>
@@ -139,7 +139,7 @@
             <p14:sldId id="265"/>
           </p14:sldIdLst>
         </p14:section>
-        <p14:section name="Train separately, average, and why it works" id="{ac5ed8ae-c788-4b0e-af99-7557b9a7fd25}">
+        <p14:section name="Train separately, average, and why it works" id="{4c545d9e-82b1-0cea-13e3-9eb080c2bc2c}">
           <p14:sldIdLst>
             <p14:sldId id="266"/>
             <p14:sldId id="267"/>
@@ -7255,146 +7255,133 @@
         </p:nvSpPr>
         <p:spPr>
           <a:xfrm>
-            <a:off x="914400" y="2331720"/>
-            <a:ext cx="4754880" cy="274320"/>
-          </a:xfrm>
-          <a:prstGeom prst="rect">
-            <a:avLst/>
-          </a:prstGeom>
-          <a:noFill/>
-          <a:ln/>
-        </p:spPr>
-        <p:txBody>
-          <a:bodyPr wrap="square" lIns="0" tIns="0" rIns="0" bIns="0" rtlCol="0" anchor="ctr"/>
-          <a:lstStyle/>
-          <a:p>
-            <a:pPr indent="0" marL="0">
-              <a:buNone/>
-            </a:pPr>
-            <a:r>
-              <a:rPr lang="en-US" sz="1100" b="1" spc="200" kern="0" dirty="0">
+            <a:off x="640080" y="2514600"/>
+            <a:ext cx="5257800" cy="274320"/>
+          </a:xfrm>
+          <a:prstGeom prst="rect">
+            <a:avLst/>
+          </a:prstGeom>
+          <a:noFill/>
+          <a:ln/>
+        </p:spPr>
+        <p:txBody>
+          <a:bodyPr wrap="square" lIns="0" tIns="0" rIns="0" bIns="0" rtlCol="0" anchor="ctr"/>
+          <a:lstStyle/>
+          <a:p>
+            <a:pPr algn="ctr" indent="0" marL="0">
+              <a:buNone/>
+            </a:pPr>
+            <a:r>
+              <a:rPr lang="en-US" sz="1200" b="1" spc="300" kern="0" dirty="0">
                 <a:solidFill>
                   <a:srgbClr val="C2410C"/>
                 </a:solidFill>
               </a:rPr>
-              <a:t>WAY 1 · IT ALREADY KNOWS IT</a:t>
-            </a:r>
-            <a:endParaRPr lang="en-US" sz="1100" dirty="0"/>
-          </a:p>
-        </p:txBody>
-      </p:sp>
-      <p:sp>
-        <p:nvSpPr>
-          <p:cNvPr id="6" name="Text 4"/>
-          <p:cNvSpPr txBox="1"/>
-          <p:nvPr/>
-        </p:nvSpPr>
-        <p:spPr>
-          <a:xfrm>
-            <a:off x="914400" y="2651760"/>
-            <a:ext cx="4754880" cy="731520"/>
-          </a:xfrm>
-          <a:prstGeom prst="rect">
-            <a:avLst/>
-          </a:prstGeom>
-          <a:noFill/>
-          <a:ln/>
-        </p:spPr>
-        <p:txBody>
-          <a:bodyPr wrap="square" lIns="0" tIns="0" rIns="0" bIns="0" rtlCol="0" anchor="t"/>
-          <a:lstStyle/>
-          <a:p>
-            <a:pPr indent="0" marL="0">
-              <a:buNone/>
-            </a:pPr>
-            <a:r>
-              <a:rPr lang="en-US" sz="1900" b="1" dirty="0">
+              <a:t>WAY 1</a:t>
+            </a:r>
+            <a:endParaRPr lang="en-US" sz="1200" dirty="0"/>
+          </a:p>
+        </p:txBody>
+      </p:sp>
+      <p:pic>
+        <p:nvPicPr>
+          <p:cNvPr id="6" name="Image 0" descr="preencoded.png">    </p:cNvPr>
+          <p:cNvPicPr>
+            <a:picLocks noChangeAspect="1"/>
+          </p:cNvPicPr>
+          <p:nvPr/>
+        </p:nvPicPr>
+        <p:blipFill>
+          <a:blip r:embed="rId1"/>
+          <a:stretch>
+            <a:fillRect/>
+          </a:stretch>
+        </p:blipFill>
+        <p:spPr>
+          <a:xfrm>
+            <a:off x="2720340" y="2926080"/>
+            <a:ext cx="1097280" cy="1097280"/>
+          </a:xfrm>
+          <a:prstGeom prst="rect">
+            <a:avLst/>
+          </a:prstGeom>
+        </p:spPr>
+      </p:pic>
+      <p:sp>
+        <p:nvSpPr>
+          <p:cNvPr id="7" name="Text 4"/>
+          <p:cNvSpPr txBox="1"/>
+          <p:nvPr/>
+        </p:nvSpPr>
+        <p:spPr>
+          <a:xfrm>
+            <a:off x="640080" y="4206240"/>
+            <a:ext cx="5257800" cy="548640"/>
+          </a:xfrm>
+          <a:prstGeom prst="rect">
+            <a:avLst/>
+          </a:prstGeom>
+          <a:noFill/>
+          <a:ln/>
+        </p:spPr>
+        <p:txBody>
+          <a:bodyPr wrap="square" lIns="0" tIns="0" rIns="0" bIns="0" rtlCol="0" anchor="ctr"/>
+          <a:lstStyle/>
+          <a:p>
+            <a:pPr algn="ctr" indent="0" marL="0">
+              <a:buNone/>
+            </a:pPr>
+            <a:r>
+              <a:rPr lang="en-US" sz="2600" b="1" dirty="0">
                 <a:solidFill>
                   <a:srgbClr val="111827"/>
                 </a:solidFill>
               </a:rPr>
-              <a:t>The knowledge is in there, it just doesn't come out</a:t>
-            </a:r>
-            <a:endParaRPr lang="en-US" sz="1900" dirty="0"/>
-          </a:p>
-        </p:txBody>
-      </p:sp>
-      <p:sp>
-        <p:nvSpPr>
-          <p:cNvPr id="7" name="Text 5"/>
-          <p:cNvSpPr txBox="1"/>
-          <p:nvPr/>
-        </p:nvSpPr>
-        <p:spPr>
-          <a:xfrm>
-            <a:off x="914400" y="3429000"/>
-            <a:ext cx="4754880" cy="2286000"/>
-          </a:xfrm>
-          <a:prstGeom prst="rect">
-            <a:avLst/>
-          </a:prstGeom>
-          <a:noFill/>
-          <a:ln/>
-        </p:spPr>
-        <p:txBody>
-          <a:bodyPr wrap="square" lIns="0" tIns="0" rIns="0" bIns="0" rtlCol="0" anchor="t"/>
-          <a:lstStyle/>
-          <a:p>
-            <a:pPr indent="0" marL="0">
-              <a:spcAft>
-                <a:spcPts val="600"/>
-              </a:spcAft>
-              <a:buNone/>
-            </a:pPr>
-            <a:r>
-              <a:rPr lang="en-US" sz="1400" dirty="0">
-                <a:solidFill>
-                  <a:srgbClr val="374151"/>
-                </a:solidFill>
-              </a:rPr>
-              <a:t>1   Does the model know more than it says?</a:t>
-            </a:r>
-            <a:endParaRPr lang="en-US" sz="1400" dirty="0"/>
-          </a:p>
-          <a:p>
-            <a:pPr indent="0" marL="0">
-              <a:spcAft>
-                <a:spcPts val="600"/>
-              </a:spcAft>
-              <a:buNone/>
-            </a:pPr>
-            <a:r>
-              <a:rPr lang="en-US" sz="1400" dirty="0">
-                <a:solidFill>
-                  <a:srgbClr val="374151"/>
-                </a:solidFill>
-              </a:rPr>
-              <a:t>2   Can we get it out without training?</a:t>
-            </a:r>
-            <a:endParaRPr lang="en-US" sz="1400" dirty="0"/>
-          </a:p>
-          <a:p>
-            <a:pPr indent="0" marL="0">
-              <a:spcAft>
-                <a:spcPts val="600"/>
-              </a:spcAft>
-              <a:buNone/>
-            </a:pPr>
-            <a:r>
-              <a:rPr lang="en-US" sz="1400" dirty="0">
-                <a:solidFill>
-                  <a:srgbClr val="374151"/>
-                </a:solidFill>
-              </a:rPr>
-              <a:t>3   Where should we nudge?</a:t>
-            </a:r>
-            <a:endParaRPr lang="en-US" sz="1400" dirty="0"/>
-          </a:p>
-        </p:txBody>
-      </p:sp>
-      <p:sp>
-        <p:nvSpPr>
-          <p:cNvPr id="8" name="Shape 6"/>
+              <a:t>It already knows it</a:t>
+            </a:r>
+            <a:endParaRPr lang="en-US" sz="2600" dirty="0"/>
+          </a:p>
+        </p:txBody>
+      </p:sp>
+      <p:sp>
+        <p:nvSpPr>
+          <p:cNvPr id="8" name="Text 5"/>
+          <p:cNvSpPr txBox="1"/>
+          <p:nvPr/>
+        </p:nvSpPr>
+        <p:spPr>
+          <a:xfrm>
+            <a:off x="640080" y="4800600"/>
+            <a:ext cx="5257800" cy="365760"/>
+          </a:xfrm>
+          <a:prstGeom prst="rect">
+            <a:avLst/>
+          </a:prstGeom>
+          <a:noFill/>
+          <a:ln/>
+        </p:spPr>
+        <p:txBody>
+          <a:bodyPr wrap="square" lIns="0" tIns="0" rIns="0" bIns="0" rtlCol="0" anchor="ctr"/>
+          <a:lstStyle/>
+          <a:p>
+            <a:pPr algn="ctr" indent="0" marL="0">
+              <a:buNone/>
+            </a:pPr>
+            <a:r>
+              <a:rPr lang="en-US" sz="1600" dirty="0">
+                <a:solidFill>
+                  <a:srgbClr val="6B7280"/>
+                </a:solidFill>
+              </a:rPr>
+              <a:t>3 questions</a:t>
+            </a:r>
+            <a:endParaRPr lang="en-US" sz="1600" dirty="0"/>
+          </a:p>
+        </p:txBody>
+      </p:sp>
+      <p:sp>
+        <p:nvSpPr>
+          <p:cNvPr id="9" name="Shape 6"/>
           <p:cNvSpPr/>
           <p:nvPr/>
         </p:nvSpPr>
@@ -7421,203 +7408,139 @@
       </p:sp>
       <p:sp>
         <p:nvSpPr>
-          <p:cNvPr id="9" name="Text 7"/>
-          <p:cNvSpPr txBox="1"/>
-          <p:nvPr/>
-        </p:nvSpPr>
-        <p:spPr>
-          <a:xfrm>
-            <a:off x="6537960" y="2331720"/>
-            <a:ext cx="4754880" cy="274320"/>
-          </a:xfrm>
-          <a:prstGeom prst="rect">
-            <a:avLst/>
-          </a:prstGeom>
-          <a:noFill/>
-          <a:ln/>
-        </p:spPr>
-        <p:txBody>
-          <a:bodyPr wrap="square" lIns="0" tIns="0" rIns="0" bIns="0" rtlCol="0" anchor="ctr"/>
-          <a:lstStyle/>
-          <a:p>
-            <a:pPr indent="0" marL="0">
-              <a:buNone/>
-            </a:pPr>
-            <a:r>
-              <a:rPr lang="en-US" sz="1100" b="1" spc="200" kern="0" dirty="0">
+          <p:cNvPr id="10" name="Text 7"/>
+          <p:cNvSpPr txBox="1"/>
+          <p:nvPr/>
+        </p:nvSpPr>
+        <p:spPr>
+          <a:xfrm>
+            <a:off x="6263640" y="2514600"/>
+            <a:ext cx="5257800" cy="274320"/>
+          </a:xfrm>
+          <a:prstGeom prst="rect">
+            <a:avLst/>
+          </a:prstGeom>
+          <a:noFill/>
+          <a:ln/>
+        </p:spPr>
+        <p:txBody>
+          <a:bodyPr wrap="square" lIns="0" tIns="0" rIns="0" bIns="0" rtlCol="0" anchor="ctr"/>
+          <a:lstStyle/>
+          <a:p>
+            <a:pPr algn="ctr" indent="0" marL="0">
+              <a:buNone/>
+            </a:pPr>
+            <a:r>
+              <a:rPr lang="en-US" sz="1200" b="1" spc="300" kern="0" dirty="0">
                 <a:solidFill>
                   <a:srgbClr val="C2410C"/>
                 </a:solidFill>
               </a:rPr>
-              <a:t>WAY 2 · IT NEVER READ IT</a:t>
-            </a:r>
-            <a:endParaRPr lang="en-US" sz="1100" dirty="0"/>
-          </a:p>
-        </p:txBody>
-      </p:sp>
-      <p:sp>
-        <p:nvSpPr>
-          <p:cNvPr id="10" name="Text 8"/>
-          <p:cNvSpPr txBox="1"/>
-          <p:nvPr/>
-        </p:nvSpPr>
-        <p:spPr>
-          <a:xfrm>
-            <a:off x="6537960" y="2651760"/>
-            <a:ext cx="4754880" cy="731520"/>
-          </a:xfrm>
-          <a:prstGeom prst="rect">
-            <a:avLst/>
-          </a:prstGeom>
-          <a:noFill/>
-          <a:ln/>
-        </p:spPr>
-        <p:txBody>
-          <a:bodyPr wrap="square" lIns="0" tIns="0" rIns="0" bIns="0" rtlCol="0" anchor="t"/>
-          <a:lstStyle/>
-          <a:p>
-            <a:pPr indent="0" marL="0">
-              <a:buNone/>
-            </a:pPr>
-            <a:r>
-              <a:rPr lang="en-US" sz="1900" b="1" dirty="0">
+              <a:t>WAY 2</a:t>
+            </a:r>
+            <a:endParaRPr lang="en-US" sz="1200" dirty="0"/>
+          </a:p>
+        </p:txBody>
+      </p:sp>
+      <p:pic>
+        <p:nvPicPr>
+          <p:cNvPr id="11" name="Image 1" descr="preencoded.png">    </p:cNvPr>
+          <p:cNvPicPr>
+            <a:picLocks noChangeAspect="1"/>
+          </p:cNvPicPr>
+          <p:nvPr/>
+        </p:nvPicPr>
+        <p:blipFill>
+          <a:blip r:embed="rId2"/>
+          <a:stretch>
+            <a:fillRect/>
+          </a:stretch>
+        </p:blipFill>
+        <p:spPr>
+          <a:xfrm>
+            <a:off x="8343900" y="2926080"/>
+            <a:ext cx="1097280" cy="1097280"/>
+          </a:xfrm>
+          <a:prstGeom prst="rect">
+            <a:avLst/>
+          </a:prstGeom>
+        </p:spPr>
+      </p:pic>
+      <p:sp>
+        <p:nvSpPr>
+          <p:cNvPr id="12" name="Text 8"/>
+          <p:cNvSpPr txBox="1"/>
+          <p:nvPr/>
+        </p:nvSpPr>
+        <p:spPr>
+          <a:xfrm>
+            <a:off x="6263640" y="4206240"/>
+            <a:ext cx="5257800" cy="548640"/>
+          </a:xfrm>
+          <a:prstGeom prst="rect">
+            <a:avLst/>
+          </a:prstGeom>
+          <a:noFill/>
+          <a:ln/>
+        </p:spPr>
+        <p:txBody>
+          <a:bodyPr wrap="square" lIns="0" tIns="0" rIns="0" bIns="0" rtlCol="0" anchor="ctr"/>
+          <a:lstStyle/>
+          <a:p>
+            <a:pPr algn="ctr" indent="0" marL="0">
+              <a:buNone/>
+            </a:pPr>
+            <a:r>
+              <a:rPr lang="en-US" sz="2600" b="1" dirty="0">
                 <a:solidFill>
                   <a:srgbClr val="111827"/>
                 </a:solidFill>
               </a:rPr>
-              <a:t>Yesterday's news: now it has to learn</a:t>
-            </a:r>
-            <a:endParaRPr lang="en-US" sz="1900" dirty="0"/>
-          </a:p>
-        </p:txBody>
-      </p:sp>
-      <p:sp>
-        <p:nvSpPr>
-          <p:cNvPr id="11" name="Text 9"/>
-          <p:cNvSpPr txBox="1"/>
-          <p:nvPr/>
-        </p:nvSpPr>
-        <p:spPr>
-          <a:xfrm>
-            <a:off x="6537960" y="3429000"/>
-            <a:ext cx="4754880" cy="2286000"/>
-          </a:xfrm>
-          <a:prstGeom prst="rect">
-            <a:avLst/>
-          </a:prstGeom>
-          <a:noFill/>
-          <a:ln/>
-        </p:spPr>
-        <p:txBody>
-          <a:bodyPr wrap="square" lIns="0" tIns="0" rIns="0" bIns="0" rtlCol="0" anchor="t"/>
-          <a:lstStyle/>
-          <a:p>
-            <a:pPr indent="0" marL="0">
-              <a:spcAft>
-                <a:spcPts val="600"/>
-              </a:spcAft>
-              <a:buNone/>
-            </a:pPr>
-            <a:r>
-              <a:rPr lang="en-US" sz="1400" dirty="0">
-                <a:solidFill>
-                  <a:srgbClr val="374151"/>
-                </a:solidFill>
-              </a:rPr>
-              <a:t>4   How do we teach it, cheaply?</a:t>
-            </a:r>
-            <a:endParaRPr lang="en-US" sz="1400" dirty="0"/>
-          </a:p>
-          <a:p>
-            <a:pPr indent="0" marL="0">
-              <a:spcAft>
-                <a:spcPts val="600"/>
-              </a:spcAft>
-              <a:buNone/>
-            </a:pPr>
-            <a:r>
-              <a:rPr lang="en-US" sz="1400" dirty="0">
-                <a:solidFill>
-                  <a:srgbClr val="374151"/>
-                </a:solidFill>
-              </a:rPr>
-              <a:t>5   Taught in English, does it know it in German?</a:t>
-            </a:r>
-            <a:endParaRPr lang="en-US" sz="1400" dirty="0"/>
-          </a:p>
-          <a:p>
-            <a:pPr indent="0" marL="0">
-              <a:spcAft>
-                <a:spcPts val="600"/>
-              </a:spcAft>
-              <a:buNone/>
-            </a:pPr>
-            <a:r>
-              <a:rPr lang="en-US" sz="1400" dirty="0">
-                <a:solidFill>
-                  <a:srgbClr val="374151"/>
-                </a:solidFill>
-              </a:rPr>
-              <a:t>6   What decides how much it learns?</a:t>
-            </a:r>
-            <a:endParaRPr lang="en-US" sz="1400" dirty="0"/>
-          </a:p>
-          <a:p>
-            <a:pPr indent="0" marL="0">
-              <a:spcAft>
-                <a:spcPts val="600"/>
-              </a:spcAft>
-              <a:buNone/>
-            </a:pPr>
-            <a:r>
-              <a:rPr lang="en-US" sz="1400" dirty="0">
-                <a:solidFill>
-                  <a:srgbClr val="374151"/>
-                </a:solidFill>
-              </a:rPr>
-              <a:t>7   What does it cost?</a:t>
-            </a:r>
-            <a:endParaRPr lang="en-US" sz="1400" dirty="0"/>
-          </a:p>
-          <a:p>
-            <a:pPr indent="0" marL="0">
-              <a:spcAft>
-                <a:spcPts val="600"/>
-              </a:spcAft>
-              <a:buNone/>
-            </a:pPr>
-            <a:r>
-              <a:rPr lang="en-US" sz="1400" dirty="0">
-                <a:solidFill>
-                  <a:srgbClr val="374151"/>
-                </a:solidFill>
-              </a:rPr>
-              <a:t>8   Can we keep the facts without the cost?</a:t>
-            </a:r>
-            <a:endParaRPr lang="en-US" sz="1400" dirty="0"/>
-          </a:p>
-          <a:p>
-            <a:pPr indent="0" marL="0">
-              <a:spcAft>
-                <a:spcPts val="600"/>
-              </a:spcAft>
-              <a:buNone/>
-            </a:pPr>
-            <a:r>
-              <a:rPr lang="en-US" sz="1400" dirty="0">
-                <a:solidFill>
-                  <a:srgbClr val="374151"/>
-                </a:solidFill>
-              </a:rPr>
-              <a:t>9   Why does that work?</a:t>
-            </a:r>
-            <a:endParaRPr lang="en-US" sz="1400" dirty="0"/>
-          </a:p>
-        </p:txBody>
-      </p:sp>
-      <p:sp>
-        <p:nvSpPr>
-          <p:cNvPr id="12" name="Text 0"/>
+              <a:t>It never read it</a:t>
+            </a:r>
+            <a:endParaRPr lang="en-US" sz="2600" dirty="0"/>
+          </a:p>
+        </p:txBody>
+      </p:sp>
+      <p:sp>
+        <p:nvSpPr>
+          <p:cNvPr id="13" name="Text 9"/>
+          <p:cNvSpPr txBox="1"/>
+          <p:nvPr/>
+        </p:nvSpPr>
+        <p:spPr>
+          <a:xfrm>
+            <a:off x="6263640" y="4800600"/>
+            <a:ext cx="5257800" cy="365760"/>
+          </a:xfrm>
+          <a:prstGeom prst="rect">
+            <a:avLst/>
+          </a:prstGeom>
+          <a:noFill/>
+          <a:ln/>
+        </p:spPr>
+        <p:txBody>
+          <a:bodyPr wrap="square" lIns="0" tIns="0" rIns="0" bIns="0" rtlCol="0" anchor="ctr"/>
+          <a:lstStyle/>
+          <a:p>
+            <a:pPr algn="ctr" indent="0" marL="0">
+              <a:buNone/>
+            </a:pPr>
+            <a:r>
+              <a:rPr lang="en-US" sz="1600" dirty="0">
+                <a:solidFill>
+                  <a:srgbClr val="6B7280"/>
+                </a:solidFill>
+              </a:rPr>
+              <a:t>6 questions</a:t>
+            </a:r>
+            <a:endParaRPr lang="en-US" sz="1600" dirty="0"/>
+          </a:p>
+        </p:txBody>
+      </p:sp>
+      <p:sp>
+        <p:nvSpPr>
+          <p:cNvPr id="14" name="Text 0"/>
           <p:cNvSpPr/>
           <p:nvPr>
             <p:ph idx="102" type="body" hasCustomPrompt="1"/>
@@ -7647,7 +7570,7 @@
                   <a:schemeClr val="tx1"/>
                 </a:solidFill>
               </a:rPr>
-              <a:t>Nine small questions. </a:t>
+              <a:t>Nine questions. </a:t>
             </a:r>
             <a:pPr indent="0" marL="0">
               <a:buNone/>

</xml_diff>